<commit_message>
Both decks: Result 3 is now the model, not the implementation
The advisor deck's Result 3 asked the wrong question. It headlined two
versions of one defense disagreeing, which is true on Mistral and false on
Llama-3. The slide now shows all four cells - two models by two versions -
where the undefended arm never refuses and the defended arm reaches 85% on one
model and 5.7% on the other.

Result 2 drops its RobustRAG rows and keeps the context-reliance story alone,
so each slide carries one message instead of two.

The full results deck gets the same treatment.

Co-Authored-By: Claude Opus 5 <noreply@anthropic.com>
</commit_message>
<xml_diff>
--- a/advisor_meeting.pptx
+++ b/advisor_meeting.pptx
@@ -3428,7 +3428,7 @@
                 </a:solidFill>
                 <a:latin typeface="Calibri"/>
               </a:rPr>
-              <a:t>16 defense and attack pairs. 94 measured conditions. Four attacks. Five defenses. Three models.</a:t>
+              <a:t>18 defense and attack pairs. 104 measured conditions. Four attacks. Five defenses. Three models.</a:t>
             </a:r>
           </a:p>
           <a:p>
@@ -4179,7 +4179,7 @@
                 </a:solidFill>
                 <a:latin typeface="Calibri"/>
               </a:rPr>
-              <a:t>0 of 8</a:t>
+              <a:t>0 of 10</a:t>
             </a:r>
           </a:p>
         </p:txBody>
@@ -4500,8 +4500,8 @@
         </p:nvSpPr>
         <p:spPr>
           <a:xfrm>
-            <a:off x="731520" y="2267712"/>
-            <a:ext cx="3931920" cy="274320"/>
+            <a:off x="731520" y="2103120"/>
+            <a:ext cx="2926080" cy="274320"/>
           </a:xfrm>
           <a:prstGeom prst="rect">
             <a:avLst/>
@@ -4542,8 +4542,8 @@
         </p:nvSpPr>
         <p:spPr>
           <a:xfrm>
-            <a:off x="4754880" y="2267712"/>
-            <a:ext cx="2103120" cy="274320"/>
+            <a:off x="3749039" y="2103120"/>
+            <a:ext cx="2377440" cy="274320"/>
           </a:xfrm>
           <a:prstGeom prst="rect">
             <a:avLst/>
@@ -4584,8 +4584,8 @@
         </p:nvSpPr>
         <p:spPr>
           <a:xfrm>
-            <a:off x="7040880" y="2267712"/>
-            <a:ext cx="1463040" cy="274320"/>
+            <a:off x="6309359" y="2103120"/>
+            <a:ext cx="1645920" cy="274320"/>
           </a:xfrm>
           <a:prstGeom prst="rect">
             <a:avLst/>
@@ -4626,8 +4626,8 @@
         </p:nvSpPr>
         <p:spPr>
           <a:xfrm>
-            <a:off x="8686800" y="2267712"/>
-            <a:ext cx="1828800" cy="274320"/>
+            <a:off x="8138160" y="2103120"/>
+            <a:ext cx="2011680" cy="274320"/>
           </a:xfrm>
           <a:prstGeom prst="rect">
             <a:avLst/>
@@ -4668,8 +4668,8 @@
         </p:nvSpPr>
         <p:spPr>
           <a:xfrm>
-            <a:off x="10698480" y="2267712"/>
-            <a:ext cx="1097280" cy="274320"/>
+            <a:off x="10332720" y="2103120"/>
+            <a:ext cx="1280160" cy="274320"/>
           </a:xfrm>
           <a:prstGeom prst="rect">
             <a:avLst/>
@@ -4710,8 +4710,8 @@
         </p:nvSpPr>
         <p:spPr>
           <a:xfrm>
-            <a:off x="731520" y="2615184"/>
-            <a:ext cx="3931920" cy="310896"/>
+            <a:off x="731520" y="2450592"/>
+            <a:ext cx="2926080" cy="310896"/>
           </a:xfrm>
           <a:prstGeom prst="rect">
             <a:avLst/>
@@ -4752,8 +4752,8 @@
         </p:nvSpPr>
         <p:spPr>
           <a:xfrm>
-            <a:off x="4754880" y="2615184"/>
-            <a:ext cx="2103120" cy="310896"/>
+            <a:off x="3749039" y="2450592"/>
+            <a:ext cx="2377440" cy="310896"/>
           </a:xfrm>
           <a:prstGeom prst="rect">
             <a:avLst/>
@@ -4794,8 +4794,8 @@
         </p:nvSpPr>
         <p:spPr>
           <a:xfrm>
-            <a:off x="7040880" y="2615184"/>
-            <a:ext cx="1463040" cy="310896"/>
+            <a:off x="6309359" y="2450592"/>
+            <a:ext cx="1645920" cy="310896"/>
           </a:xfrm>
           <a:prstGeom prst="rect">
             <a:avLst/>
@@ -4836,8 +4836,8 @@
         </p:nvSpPr>
         <p:spPr>
           <a:xfrm>
-            <a:off x="8686800" y="2615184"/>
-            <a:ext cx="1828800" cy="310896"/>
+            <a:off x="8138160" y="2450592"/>
+            <a:ext cx="2011680" cy="310896"/>
           </a:xfrm>
           <a:prstGeom prst="rect">
             <a:avLst/>
@@ -4878,8 +4878,8 @@
         </p:nvSpPr>
         <p:spPr>
           <a:xfrm>
-            <a:off x="10698480" y="2615184"/>
-            <a:ext cx="1097280" cy="310896"/>
+            <a:off x="10332720" y="2450592"/>
+            <a:ext cx="1280160" cy="310896"/>
           </a:xfrm>
           <a:prstGeom prst="rect">
             <a:avLst/>
@@ -4920,8 +4920,8 @@
         </p:nvSpPr>
         <p:spPr>
           <a:xfrm>
-            <a:off x="731520" y="3090672"/>
-            <a:ext cx="3931920" cy="310896"/>
+            <a:off x="731520" y="2926080"/>
+            <a:ext cx="2926080" cy="310896"/>
           </a:xfrm>
           <a:prstGeom prst="rect">
             <a:avLst/>
@@ -4962,8 +4962,8 @@
         </p:nvSpPr>
         <p:spPr>
           <a:xfrm>
-            <a:off x="4754880" y="3090672"/>
-            <a:ext cx="2103120" cy="310896"/>
+            <a:off x="3749039" y="2926080"/>
+            <a:ext cx="2377440" cy="310896"/>
           </a:xfrm>
           <a:prstGeom prst="rect">
             <a:avLst/>
@@ -5004,8 +5004,8 @@
         </p:nvSpPr>
         <p:spPr>
           <a:xfrm>
-            <a:off x="7040880" y="3090672"/>
-            <a:ext cx="1463040" cy="310896"/>
+            <a:off x="6309359" y="2926080"/>
+            <a:ext cx="1645920" cy="310896"/>
           </a:xfrm>
           <a:prstGeom prst="rect">
             <a:avLst/>
@@ -5046,8 +5046,8 @@
         </p:nvSpPr>
         <p:spPr>
           <a:xfrm>
-            <a:off x="8686800" y="3090672"/>
-            <a:ext cx="1828800" cy="310896"/>
+            <a:off x="8138160" y="2926080"/>
+            <a:ext cx="2011680" cy="310896"/>
           </a:xfrm>
           <a:prstGeom prst="rect">
             <a:avLst/>
@@ -5088,8 +5088,8 @@
         </p:nvSpPr>
         <p:spPr>
           <a:xfrm>
-            <a:off x="10698480" y="3090672"/>
-            <a:ext cx="1097280" cy="310896"/>
+            <a:off x="10332720" y="2926080"/>
+            <a:ext cx="1280160" cy="310896"/>
           </a:xfrm>
           <a:prstGeom prst="rect">
             <a:avLst/>
@@ -5130,8 +5130,8 @@
         </p:nvSpPr>
         <p:spPr>
           <a:xfrm>
-            <a:off x="731520" y="3566160"/>
-            <a:ext cx="3931920" cy="310896"/>
+            <a:off x="731520" y="3401568"/>
+            <a:ext cx="2926080" cy="310896"/>
           </a:xfrm>
           <a:prstGeom prst="rect">
             <a:avLst/>
@@ -5159,7 +5159,7 @@
                 </a:solidFill>
                 <a:latin typeface="Calibri"/>
               </a:rPr>
-              <a:t>RobustRAG, on Llama-3</a:t>
+              <a:t>ParamMute</a:t>
             </a:r>
           </a:p>
         </p:txBody>
@@ -5172,8 +5172,8 @@
         </p:nvSpPr>
         <p:spPr>
           <a:xfrm>
-            <a:off x="4754880" y="3566160"/>
-            <a:ext cx="2103120" cy="310896"/>
+            <a:off x="3749039" y="3401568"/>
+            <a:ext cx="2377440" cy="310896"/>
           </a:xfrm>
           <a:prstGeom prst="rect">
             <a:avLst/>
@@ -5201,7 +5201,7 @@
                 </a:solidFill>
                 <a:latin typeface="Calibri"/>
               </a:rPr>
-              <a:t>refusal</a:t>
+              <a:t>tone steering</a:t>
             </a:r>
           </a:p>
         </p:txBody>
@@ -5214,8 +5214,8 @@
         </p:nvSpPr>
         <p:spPr>
           <a:xfrm>
-            <a:off x="7040880" y="3566160"/>
-            <a:ext cx="1463040" cy="310896"/>
+            <a:off x="6309359" y="3401568"/>
+            <a:ext cx="1645920" cy="310896"/>
           </a:xfrm>
           <a:prstGeom prst="rect">
             <a:avLst/>
@@ -5243,7 +5243,7 @@
                 </a:solidFill>
                 <a:latin typeface="Calibri"/>
               </a:rPr>
-              <a:t>0.0 %</a:t>
+              <a:t>3.4 %</a:t>
             </a:r>
           </a:p>
         </p:txBody>
@@ -5256,8 +5256,8 @@
         </p:nvSpPr>
         <p:spPr>
           <a:xfrm>
-            <a:off x="8686800" y="3566160"/>
-            <a:ext cx="1828800" cy="310896"/>
+            <a:off x="8138160" y="3401568"/>
+            <a:ext cx="2011680" cy="310896"/>
           </a:xfrm>
           <a:prstGeom prst="rect">
             <a:avLst/>
@@ -5285,7 +5285,7 @@
                 </a:solidFill>
                 <a:latin typeface="Calibri"/>
               </a:rPr>
-              <a:t>85.0 %</a:t>
+              <a:t>28.8 %</a:t>
             </a:r>
           </a:p>
         </p:txBody>
@@ -5298,8 +5298,8 @@
         </p:nvSpPr>
         <p:spPr>
           <a:xfrm>
-            <a:off x="10698480" y="3566160"/>
-            <a:ext cx="1097280" cy="310896"/>
+            <a:off x="10332720" y="3401568"/>
+            <a:ext cx="1280160" cy="310896"/>
           </a:xfrm>
           <a:prstGeom prst="rect">
             <a:avLst/>
@@ -5327,7 +5327,7 @@
                 </a:solidFill>
                 <a:latin typeface="Calibri"/>
               </a:rPr>
-              <a:t>9 of 10</a:t>
+              <a:t>10 of 10</a:t>
             </a:r>
           </a:p>
         </p:txBody>
@@ -5340,36 +5340,93 @@
         </p:nvSpPr>
         <p:spPr>
           <a:xfrm>
-            <a:off x="731520" y="4041648"/>
-            <a:ext cx="3931920" cy="310896"/>
-          </a:xfrm>
-          <a:prstGeom prst="rect">
-            <a:avLst/>
-          </a:prstGeom>
-          <a:noFill/>
-        </p:spPr>
-        <p:txBody>
-          <a:bodyPr wrap="square" lIns="0" rIns="0" tIns="0" bIns="0" anchor="t">
-            <a:spAutoFit/>
-          </a:bodyPr>
-          <a:lstStyle/>
-          <a:p>
-            <a:pPr algn="l">
-              <a:lnSpc>
-                <a:spcPct val="106000"/>
-              </a:lnSpc>
-              <a:spcAft>
-                <a:spcPts val="0"/>
-              </a:spcAft>
-            </a:pPr>
-            <a:r>
-              <a:rPr sz="1350" b="0" i="0">
+            <a:off x="731520" y="4114800"/>
+            <a:ext cx="10725912" cy="2286000"/>
+          </a:xfrm>
+          <a:prstGeom prst="rect">
+            <a:avLst/>
+          </a:prstGeom>
+          <a:noFill/>
+        </p:spPr>
+        <p:txBody>
+          <a:bodyPr wrap="square" lIns="0" rIns="0" tIns="0" bIns="0" anchor="t">
+            <a:spAutoFit/>
+          </a:bodyPr>
+          <a:lstStyle/>
+          <a:p>
+            <a:pPr algn="l">
+              <a:lnSpc>
+                <a:spcPct val="110000"/>
+              </a:lnSpc>
+              <a:spcAft>
+                <a:spcPts val="1100"/>
+              </a:spcAft>
+            </a:pPr>
+            <a:r>
+              <a:rPr sz="1500" b="1" i="0">
+                <a:solidFill>
+                  <a:srgbClr val="111111"/>
+                </a:solidFill>
+                <a:latin typeface="Calibri"/>
+              </a:rPr>
+              <a:t>With no defense the attack stays at or near zero. It only works once the defense is switched on.</a:t>
+            </a:r>
+          </a:p>
+          <a:p>
+            <a:pPr>
+              <a:lnSpc>
+                <a:spcPct val="110000"/>
+              </a:lnSpc>
+              <a:spcAft>
+                <a:spcPts val="1100"/>
+              </a:spcAft>
+            </a:pPr>
+            <a:r>
+              <a:rPr sz="1500" b="0" i="0">
                 <a:solidFill>
                   <a:srgbClr val="444444"/>
                 </a:solidFill>
                 <a:latin typeface="Calibri"/>
               </a:rPr>
-              <a:t>RobustRAG, on Mistral</a:t>
+              <a:t>One poisoned passage out of ten is enough. The undefended model ignores it completely.</a:t>
+            </a:r>
+          </a:p>
+          <a:p>
+            <a:pPr>
+              <a:lnSpc>
+                <a:spcPct val="110000"/>
+              </a:lnSpc>
+              <a:spcAft>
+                <a:spcPts val="1100"/>
+              </a:spcAft>
+            </a:pPr>
+            <a:r>
+              <a:rPr sz="1500" b="0" i="0">
+                <a:solidFill>
+                  <a:srgbClr val="444444"/>
+                </a:solidFill>
+                <a:latin typeface="Calibri"/>
+              </a:rPr>
+              <a:t>The reason is uncomfortable. Tone steering does not change the answer, so a defense that pushes the model to follow the retrieved text follows the slant as well, and scores itself as working perfectly. The attack and the defense want the same thing.</a:t>
+            </a:r>
+          </a:p>
+          <a:p>
+            <a:pPr>
+              <a:lnSpc>
+                <a:spcPct val="110000"/>
+              </a:lnSpc>
+              <a:spcAft>
+                <a:spcPts val="1100"/>
+              </a:spcAft>
+            </a:pPr>
+            <a:r>
+              <a:rPr sz="1500" b="1" i="0">
+                <a:solidFill>
+                  <a:srgbClr val="111111"/>
+                </a:solidFill>
+                <a:latin typeface="Calibri"/>
+              </a:rPr>
+              <a:t>A defense can be the reason an attack succeeds. That is a security finding, not a performance note.</a:t>
             </a:r>
           </a:p>
         </p:txBody>
@@ -5377,254 +5434,6 @@
       <p:sp>
         <p:nvSpPr>
           <p:cNvPr id="26" name="TextBox 25"/>
-          <p:cNvSpPr txBox="1"/>
-          <p:nvPr/>
-        </p:nvSpPr>
-        <p:spPr>
-          <a:xfrm>
-            <a:off x="4754880" y="4041648"/>
-            <a:ext cx="2103120" cy="310896"/>
-          </a:xfrm>
-          <a:prstGeom prst="rect">
-            <a:avLst/>
-          </a:prstGeom>
-          <a:noFill/>
-        </p:spPr>
-        <p:txBody>
-          <a:bodyPr wrap="square" lIns="0" rIns="0" tIns="0" bIns="0" anchor="t">
-            <a:spAutoFit/>
-          </a:bodyPr>
-          <a:lstStyle/>
-          <a:p>
-            <a:pPr algn="l">
-              <a:lnSpc>
-                <a:spcPct val="106000"/>
-              </a:lnSpc>
-              <a:spcAft>
-                <a:spcPts val="0"/>
-              </a:spcAft>
-            </a:pPr>
-            <a:r>
-              <a:rPr sz="1350" b="0" i="0">
-                <a:solidFill>
-                  <a:srgbClr val="444444"/>
-                </a:solidFill>
-                <a:latin typeface="Calibri"/>
-              </a:rPr>
-              <a:t>refusal</a:t>
-            </a:r>
-          </a:p>
-        </p:txBody>
-      </p:sp>
-      <p:sp>
-        <p:nvSpPr>
-          <p:cNvPr id="27" name="TextBox 26"/>
-          <p:cNvSpPr txBox="1"/>
-          <p:nvPr/>
-        </p:nvSpPr>
-        <p:spPr>
-          <a:xfrm>
-            <a:off x="7040880" y="4041648"/>
-            <a:ext cx="1463040" cy="310896"/>
-          </a:xfrm>
-          <a:prstGeom prst="rect">
-            <a:avLst/>
-          </a:prstGeom>
-          <a:noFill/>
-        </p:spPr>
-        <p:txBody>
-          <a:bodyPr wrap="square" lIns="0" rIns="0" tIns="0" bIns="0" anchor="t">
-            <a:spAutoFit/>
-          </a:bodyPr>
-          <a:lstStyle/>
-          <a:p>
-            <a:pPr algn="l">
-              <a:lnSpc>
-                <a:spcPct val="106000"/>
-              </a:lnSpc>
-              <a:spcAft>
-                <a:spcPts val="0"/>
-              </a:spcAft>
-            </a:pPr>
-            <a:r>
-              <a:rPr sz="1350" b="0" i="0">
-                <a:solidFill>
-                  <a:srgbClr val="444444"/>
-                </a:solidFill>
-                <a:latin typeface="Calibri"/>
-              </a:rPr>
-              <a:t>0.0 %</a:t>
-            </a:r>
-          </a:p>
-        </p:txBody>
-      </p:sp>
-      <p:sp>
-        <p:nvSpPr>
-          <p:cNvPr id="28" name="TextBox 27"/>
-          <p:cNvSpPr txBox="1"/>
-          <p:nvPr/>
-        </p:nvSpPr>
-        <p:spPr>
-          <a:xfrm>
-            <a:off x="8686800" y="4041648"/>
-            <a:ext cx="1828800" cy="310896"/>
-          </a:xfrm>
-          <a:prstGeom prst="rect">
-            <a:avLst/>
-          </a:prstGeom>
-          <a:noFill/>
-        </p:spPr>
-        <p:txBody>
-          <a:bodyPr wrap="square" lIns="0" rIns="0" tIns="0" bIns="0" anchor="t">
-            <a:spAutoFit/>
-          </a:bodyPr>
-          <a:lstStyle/>
-          <a:p>
-            <a:pPr algn="l">
-              <a:lnSpc>
-                <a:spcPct val="106000"/>
-              </a:lnSpc>
-              <a:spcAft>
-                <a:spcPts val="0"/>
-              </a:spcAft>
-            </a:pPr>
-            <a:r>
-              <a:rPr sz="1350" b="1" i="0">
-                <a:solidFill>
-                  <a:srgbClr val="111111"/>
-                </a:solidFill>
-                <a:latin typeface="Calibri"/>
-              </a:rPr>
-              <a:t>5.7 %</a:t>
-            </a:r>
-          </a:p>
-        </p:txBody>
-      </p:sp>
-      <p:sp>
-        <p:nvSpPr>
-          <p:cNvPr id="29" name="TextBox 28"/>
-          <p:cNvSpPr txBox="1"/>
-          <p:nvPr/>
-        </p:nvSpPr>
-        <p:spPr>
-          <a:xfrm>
-            <a:off x="10698480" y="4041648"/>
-            <a:ext cx="1097280" cy="310896"/>
-          </a:xfrm>
-          <a:prstGeom prst="rect">
-            <a:avLst/>
-          </a:prstGeom>
-          <a:noFill/>
-        </p:spPr>
-        <p:txBody>
-          <a:bodyPr wrap="square" lIns="0" rIns="0" tIns="0" bIns="0" anchor="t">
-            <a:spAutoFit/>
-          </a:bodyPr>
-          <a:lstStyle/>
-          <a:p>
-            <a:pPr algn="l">
-              <a:lnSpc>
-                <a:spcPct val="106000"/>
-              </a:lnSpc>
-              <a:spcAft>
-                <a:spcPts val="0"/>
-              </a:spcAft>
-            </a:pPr>
-            <a:r>
-              <a:rPr sz="1350" b="0" i="0">
-                <a:solidFill>
-                  <a:srgbClr val="444444"/>
-                </a:solidFill>
-                <a:latin typeface="Calibri"/>
-              </a:rPr>
-              <a:t>9 of 10</a:t>
-            </a:r>
-          </a:p>
-        </p:txBody>
-      </p:sp>
-      <p:sp>
-        <p:nvSpPr>
-          <p:cNvPr id="30" name="TextBox 29"/>
-          <p:cNvSpPr txBox="1"/>
-          <p:nvPr/>
-        </p:nvSpPr>
-        <p:spPr>
-          <a:xfrm>
-            <a:off x="731520" y="4709160"/>
-            <a:ext cx="10725912" cy="1691639"/>
-          </a:xfrm>
-          <a:prstGeom prst="rect">
-            <a:avLst/>
-          </a:prstGeom>
-          <a:noFill/>
-        </p:spPr>
-        <p:txBody>
-          <a:bodyPr wrap="square" lIns="0" rIns="0" tIns="0" bIns="0" anchor="t">
-            <a:spAutoFit/>
-          </a:bodyPr>
-          <a:lstStyle/>
-          <a:p>
-            <a:pPr algn="l">
-              <a:lnSpc>
-                <a:spcPct val="110000"/>
-              </a:lnSpc>
-              <a:spcAft>
-                <a:spcPts val="1100"/>
-              </a:spcAft>
-            </a:pPr>
-            <a:r>
-              <a:rPr sz="1500" b="1" i="0">
-                <a:solidFill>
-                  <a:srgbClr val="111111"/>
-                </a:solidFill>
-                <a:latin typeface="Calibri"/>
-              </a:rPr>
-              <a:t>With no defense the attack stays at or near zero. It only works once the defense is switched on.</a:t>
-            </a:r>
-          </a:p>
-          <a:p>
-            <a:pPr>
-              <a:lnSpc>
-                <a:spcPct val="110000"/>
-              </a:lnSpc>
-              <a:spcAft>
-                <a:spcPts val="1100"/>
-              </a:spcAft>
-            </a:pPr>
-            <a:r>
-              <a:rPr sz="1500" b="0" i="0">
-                <a:solidFill>
-                  <a:srgbClr val="444444"/>
-                </a:solidFill>
-                <a:latin typeface="Calibri"/>
-              </a:rPr>
-              <a:t>Tone steering does not change the answer, so a defense that pushes the model to follow the retrieved text follows the slant as well, and scores itself as working.</a:t>
-            </a:r>
-          </a:p>
-          <a:p>
-            <a:pPr>
-              <a:lnSpc>
-                <a:spcPct val="110000"/>
-              </a:lnSpc>
-              <a:spcAft>
-                <a:spcPts val="1100"/>
-              </a:spcAft>
-            </a:pPr>
-            <a:r>
-              <a:rPr sz="1500" b="1" i="0">
-                <a:solidFill>
-                  <a:srgbClr val="111111"/>
-                </a:solidFill>
-                <a:latin typeface="Calibri"/>
-              </a:rPr>
-              <a:t>The last two rows are the same defense and the same attack on two models. It protects on one and does harm on the other. The model is part of the threat model.</a:t>
-            </a:r>
-          </a:p>
-        </p:txBody>
-      </p:sp>
-      <p:sp>
-        <p:nvSpPr>
-          <p:cNvPr id="31" name="TextBox 30"/>
           <p:cNvSpPr txBox="1"/>
           <p:nvPr/>
         </p:nvSpPr>
@@ -5659,7 +5468,7 @@
                 </a:solidFill>
                 <a:latin typeface="Calibri"/>
               </a:rPr>
-              <a:t>BadRAG Xue et al., 2024, arXiv:2406.00083   ·   RobustRAG Xiang et al., 2024, arXiv:2405.15556   ·   Measurements: this work</a:t>
+              <a:t>BadRAG Xue et al., 2024   ·   ParamMute Huang et al., NeurIPS 2025   ·   Measurements: this work</a:t>
             </a:r>
           </a:p>
         </p:txBody>
@@ -5761,7 +5570,7 @@
                 </a:solidFill>
                 <a:latin typeface="Cambria"/>
               </a:rPr>
-              <a:t>Two versions of one defense give opposite answers</a:t>
+              <a:t>One defense, two models, opposite results</a:t>
             </a:r>
           </a:p>
         </p:txBody>
@@ -5816,7 +5625,7 @@
         </p:nvSpPr>
         <p:spPr>
           <a:xfrm>
-            <a:off x="731520" y="2240280"/>
+            <a:off x="731520" y="1828800"/>
             <a:ext cx="10725912" cy="365760"/>
           </a:xfrm>
           <a:prstGeom prst="rect">
@@ -5845,7 +5654,7 @@
                 </a:solidFill>
                 <a:latin typeface="Calibri"/>
               </a:rPr>
-              <a:t>Both ship in the same paper. They isolate the same way. They differ only in how they join the answers.</a:t>
+              <a:t>One defense family, two versions of it, two models. Nine poisoned passages of ten. The number is how often the agent refuses to answer.</a:t>
             </a:r>
           </a:p>
         </p:txBody>
@@ -5858,7 +5667,7 @@
         </p:nvSpPr>
         <p:spPr>
           <a:xfrm>
-            <a:off x="731520" y="2697480"/>
+            <a:off x="731520" y="2395728"/>
             <a:ext cx="3291840" cy="274320"/>
           </a:xfrm>
           <a:prstGeom prst="rect">
@@ -5881,13 +5690,13 @@
               </a:spcAft>
             </a:pPr>
             <a:r>
-              <a:rPr sz="1200" b="1" i="0">
+              <a:rPr sz="1150" b="1" i="0">
                 <a:solidFill>
                   <a:srgbClr val="777777"/>
                 </a:solidFill>
                 <a:latin typeface="Calibri"/>
               </a:rPr>
-              <a:t>Poisoned passages of 10</a:t>
+              <a:t>Model</a:t>
             </a:r>
           </a:p>
         </p:txBody>
@@ -5900,36 +5709,36 @@
         </p:nvSpPr>
         <p:spPr>
           <a:xfrm>
-            <a:off x="4297680" y="2697480"/>
-            <a:ext cx="914400" cy="274320"/>
-          </a:xfrm>
-          <a:prstGeom prst="rect">
-            <a:avLst/>
-          </a:prstGeom>
-          <a:noFill/>
-        </p:spPr>
-        <p:txBody>
-          <a:bodyPr wrap="square" lIns="0" rIns="0" tIns="0" bIns="0" anchor="t">
-            <a:spAutoFit/>
-          </a:bodyPr>
-          <a:lstStyle/>
-          <a:p>
-            <a:pPr algn="ctr">
-              <a:lnSpc>
-                <a:spcPct val="106000"/>
-              </a:lnSpc>
-              <a:spcAft>
-                <a:spcPts val="0"/>
-              </a:spcAft>
-            </a:pPr>
-            <a:r>
-              <a:rPr sz="1200" b="1" i="0">
+            <a:off x="4114800" y="2395728"/>
+            <a:ext cx="3108960" cy="274320"/>
+          </a:xfrm>
+          <a:prstGeom prst="rect">
+            <a:avLst/>
+          </a:prstGeom>
+          <a:noFill/>
+        </p:spPr>
+        <p:txBody>
+          <a:bodyPr wrap="square" lIns="0" rIns="0" tIns="0" bIns="0" anchor="t">
+            <a:spAutoFit/>
+          </a:bodyPr>
+          <a:lstStyle/>
+          <a:p>
+            <a:pPr algn="l">
+              <a:lnSpc>
+                <a:spcPct val="106000"/>
+              </a:lnSpc>
+              <a:spcAft>
+                <a:spcPts val="0"/>
+              </a:spcAft>
+            </a:pPr>
+            <a:r>
+              <a:rPr sz="1150" b="1" i="0">
                 <a:solidFill>
                   <a:srgbClr val="777777"/>
                 </a:solidFill>
                 <a:latin typeface="Calibri"/>
               </a:rPr>
-              <a:t>1</a:t>
+              <a:t>Version of the defense</a:t>
             </a:r>
           </a:p>
         </p:txBody>
@@ -5942,36 +5751,36 @@
         </p:nvSpPr>
         <p:spPr>
           <a:xfrm>
-            <a:off x="5330952" y="2697480"/>
-            <a:ext cx="914400" cy="274320"/>
-          </a:xfrm>
-          <a:prstGeom prst="rect">
-            <a:avLst/>
-          </a:prstGeom>
-          <a:noFill/>
-        </p:spPr>
-        <p:txBody>
-          <a:bodyPr wrap="square" lIns="0" rIns="0" tIns="0" bIns="0" anchor="t">
-            <a:spAutoFit/>
-          </a:bodyPr>
-          <a:lstStyle/>
-          <a:p>
-            <a:pPr algn="ctr">
-              <a:lnSpc>
-                <a:spcPct val="106000"/>
-              </a:lnSpc>
-              <a:spcAft>
-                <a:spcPts val="0"/>
-              </a:spcAft>
-            </a:pPr>
-            <a:r>
-              <a:rPr sz="1200" b="1" i="0">
+            <a:off x="7406640" y="2395728"/>
+            <a:ext cx="1828800" cy="274320"/>
+          </a:xfrm>
+          <a:prstGeom prst="rect">
+            <a:avLst/>
+          </a:prstGeom>
+          <a:noFill/>
+        </p:spPr>
+        <p:txBody>
+          <a:bodyPr wrap="square" lIns="0" rIns="0" tIns="0" bIns="0" anchor="t">
+            <a:spAutoFit/>
+          </a:bodyPr>
+          <a:lstStyle/>
+          <a:p>
+            <a:pPr algn="l">
+              <a:lnSpc>
+                <a:spcPct val="106000"/>
+              </a:lnSpc>
+              <a:spcAft>
+                <a:spcPts val="0"/>
+              </a:spcAft>
+            </a:pPr>
+            <a:r>
+              <a:rPr sz="1150" b="1" i="0">
                 <a:solidFill>
                   <a:srgbClr val="777777"/>
                 </a:solidFill>
                 <a:latin typeface="Calibri"/>
               </a:rPr>
-              <a:t>5</a:t>
+              <a:t>No defense</a:t>
             </a:r>
           </a:p>
         </p:txBody>
@@ -5984,36 +5793,36 @@
         </p:nvSpPr>
         <p:spPr>
           <a:xfrm>
-            <a:off x="6364224" y="2697480"/>
-            <a:ext cx="914400" cy="274320"/>
-          </a:xfrm>
-          <a:prstGeom prst="rect">
-            <a:avLst/>
-          </a:prstGeom>
-          <a:noFill/>
-        </p:spPr>
-        <p:txBody>
-          <a:bodyPr wrap="square" lIns="0" rIns="0" tIns="0" bIns="0" anchor="t">
-            <a:spAutoFit/>
-          </a:bodyPr>
-          <a:lstStyle/>
-          <a:p>
-            <a:pPr algn="ctr">
-              <a:lnSpc>
-                <a:spcPct val="106000"/>
-              </a:lnSpc>
-              <a:spcAft>
-                <a:spcPts val="0"/>
-              </a:spcAft>
-            </a:pPr>
-            <a:r>
-              <a:rPr sz="1200" b="1" i="0">
+            <a:off x="9418320" y="2395728"/>
+            <a:ext cx="2103120" cy="274320"/>
+          </a:xfrm>
+          <a:prstGeom prst="rect">
+            <a:avLst/>
+          </a:prstGeom>
+          <a:noFill/>
+        </p:spPr>
+        <p:txBody>
+          <a:bodyPr wrap="square" lIns="0" rIns="0" tIns="0" bIns="0" anchor="t">
+            <a:spAutoFit/>
+          </a:bodyPr>
+          <a:lstStyle/>
+          <a:p>
+            <a:pPr algn="l">
+              <a:lnSpc>
+                <a:spcPct val="106000"/>
+              </a:lnSpc>
+              <a:spcAft>
+                <a:spcPts val="0"/>
+              </a:spcAft>
+            </a:pPr>
+            <a:r>
+              <a:rPr sz="1150" b="1" i="0">
                 <a:solidFill>
                   <a:srgbClr val="777777"/>
                 </a:solidFill>
                 <a:latin typeface="Calibri"/>
               </a:rPr>
-              <a:t>6</a:t>
+              <a:t>With the defense</a:t>
             </a:r>
           </a:p>
         </p:txBody>
@@ -6026,36 +5835,36 @@
         </p:nvSpPr>
         <p:spPr>
           <a:xfrm>
-            <a:off x="7397496" y="2697480"/>
-            <a:ext cx="914400" cy="274320"/>
-          </a:xfrm>
-          <a:prstGeom prst="rect">
-            <a:avLst/>
-          </a:prstGeom>
-          <a:noFill/>
-        </p:spPr>
-        <p:txBody>
-          <a:bodyPr wrap="square" lIns="0" rIns="0" tIns="0" bIns="0" anchor="t">
-            <a:spAutoFit/>
-          </a:bodyPr>
-          <a:lstStyle/>
-          <a:p>
-            <a:pPr algn="ctr">
-              <a:lnSpc>
-                <a:spcPct val="106000"/>
-              </a:lnSpc>
-              <a:spcAft>
-                <a:spcPts val="0"/>
-              </a:spcAft>
-            </a:pPr>
-            <a:r>
-              <a:rPr sz="1200" b="1" i="0">
-                <a:solidFill>
-                  <a:srgbClr val="777777"/>
-                </a:solidFill>
-                <a:latin typeface="Calibri"/>
-              </a:rPr>
-              <a:t>7</a:t>
+            <a:off x="731520" y="2743200"/>
+            <a:ext cx="3291840" cy="310896"/>
+          </a:xfrm>
+          <a:prstGeom prst="rect">
+            <a:avLst/>
+          </a:prstGeom>
+          <a:noFill/>
+        </p:spPr>
+        <p:txBody>
+          <a:bodyPr wrap="square" lIns="0" rIns="0" tIns="0" bIns="0" anchor="t">
+            <a:spAutoFit/>
+          </a:bodyPr>
+          <a:lstStyle/>
+          <a:p>
+            <a:pPr algn="l">
+              <a:lnSpc>
+                <a:spcPct val="106000"/>
+              </a:lnSpc>
+              <a:spcAft>
+                <a:spcPts val="0"/>
+              </a:spcAft>
+            </a:pPr>
+            <a:r>
+              <a:rPr sz="1350" b="0" i="0">
+                <a:solidFill>
+                  <a:srgbClr val="444444"/>
+                </a:solidFill>
+                <a:latin typeface="Calibri"/>
+              </a:rPr>
+              <a:t>Mistral-7B</a:t>
             </a:r>
           </a:p>
         </p:txBody>
@@ -6068,36 +5877,36 @@
         </p:nvSpPr>
         <p:spPr>
           <a:xfrm>
-            <a:off x="8430767" y="2697480"/>
-            <a:ext cx="914400" cy="274320"/>
-          </a:xfrm>
-          <a:prstGeom prst="rect">
-            <a:avLst/>
-          </a:prstGeom>
-          <a:noFill/>
-        </p:spPr>
-        <p:txBody>
-          <a:bodyPr wrap="square" lIns="0" rIns="0" tIns="0" bIns="0" anchor="t">
-            <a:spAutoFit/>
-          </a:bodyPr>
-          <a:lstStyle/>
-          <a:p>
-            <a:pPr algn="ctr">
-              <a:lnSpc>
-                <a:spcPct val="106000"/>
-              </a:lnSpc>
-              <a:spcAft>
-                <a:spcPts val="0"/>
-              </a:spcAft>
-            </a:pPr>
-            <a:r>
-              <a:rPr sz="1200" b="1" i="0">
-                <a:solidFill>
-                  <a:srgbClr val="777777"/>
-                </a:solidFill>
-                <a:latin typeface="Calibri"/>
-              </a:rPr>
-              <a:t>8</a:t>
+            <a:off x="4114800" y="2743200"/>
+            <a:ext cx="3108960" cy="310896"/>
+          </a:xfrm>
+          <a:prstGeom prst="rect">
+            <a:avLst/>
+          </a:prstGeom>
+          <a:noFill/>
+        </p:spPr>
+        <p:txBody>
+          <a:bodyPr wrap="square" lIns="0" rIns="0" tIns="0" bIns="0" anchor="t">
+            <a:spAutoFit/>
+          </a:bodyPr>
+          <a:lstStyle/>
+          <a:p>
+            <a:pPr algn="l">
+              <a:lnSpc>
+                <a:spcPct val="106000"/>
+              </a:lnSpc>
+              <a:spcAft>
+                <a:spcPts val="0"/>
+              </a:spcAft>
+            </a:pPr>
+            <a:r>
+              <a:rPr sz="1350" b="0" i="0">
+                <a:solidFill>
+                  <a:srgbClr val="444444"/>
+                </a:solidFill>
+                <a:latin typeface="Calibri"/>
+              </a:rPr>
+              <a:t>KeywordAgg</a:t>
             </a:r>
           </a:p>
         </p:txBody>
@@ -6110,36 +5919,36 @@
         </p:nvSpPr>
         <p:spPr>
           <a:xfrm>
-            <a:off x="9464040" y="2697480"/>
-            <a:ext cx="914400" cy="274320"/>
-          </a:xfrm>
-          <a:prstGeom prst="rect">
-            <a:avLst/>
-          </a:prstGeom>
-          <a:noFill/>
-        </p:spPr>
-        <p:txBody>
-          <a:bodyPr wrap="square" lIns="0" rIns="0" tIns="0" bIns="0" anchor="t">
-            <a:spAutoFit/>
-          </a:bodyPr>
-          <a:lstStyle/>
-          <a:p>
-            <a:pPr algn="ctr">
-              <a:lnSpc>
-                <a:spcPct val="106000"/>
-              </a:lnSpc>
-              <a:spcAft>
-                <a:spcPts val="0"/>
-              </a:spcAft>
-            </a:pPr>
-            <a:r>
-              <a:rPr sz="1200" b="1" i="0">
-                <a:solidFill>
-                  <a:srgbClr val="777777"/>
-                </a:solidFill>
-                <a:latin typeface="Calibri"/>
-              </a:rPr>
-              <a:t>9</a:t>
+            <a:off x="7406640" y="2743200"/>
+            <a:ext cx="1828800" cy="310896"/>
+          </a:xfrm>
+          <a:prstGeom prst="rect">
+            <a:avLst/>
+          </a:prstGeom>
+          <a:noFill/>
+        </p:spPr>
+        <p:txBody>
+          <a:bodyPr wrap="square" lIns="0" rIns="0" tIns="0" bIns="0" anchor="t">
+            <a:spAutoFit/>
+          </a:bodyPr>
+          <a:lstStyle/>
+          <a:p>
+            <a:pPr algn="l">
+              <a:lnSpc>
+                <a:spcPct val="106000"/>
+              </a:lnSpc>
+              <a:spcAft>
+                <a:spcPts val="0"/>
+              </a:spcAft>
+            </a:pPr>
+            <a:r>
+              <a:rPr sz="1350" b="0" i="0">
+                <a:solidFill>
+                  <a:srgbClr val="444444"/>
+                </a:solidFill>
+                <a:latin typeface="Calibri"/>
+              </a:rPr>
+              <a:t>0.0 %</a:t>
             </a:r>
           </a:p>
         </p:txBody>
@@ -6152,36 +5961,36 @@
         </p:nvSpPr>
         <p:spPr>
           <a:xfrm>
-            <a:off x="10497312" y="2697480"/>
-            <a:ext cx="914400" cy="274320"/>
-          </a:xfrm>
-          <a:prstGeom prst="rect">
-            <a:avLst/>
-          </a:prstGeom>
-          <a:noFill/>
-        </p:spPr>
-        <p:txBody>
-          <a:bodyPr wrap="square" lIns="0" rIns="0" tIns="0" bIns="0" anchor="t">
-            <a:spAutoFit/>
-          </a:bodyPr>
-          <a:lstStyle/>
-          <a:p>
-            <a:pPr algn="ctr">
-              <a:lnSpc>
-                <a:spcPct val="106000"/>
-              </a:lnSpc>
-              <a:spcAft>
-                <a:spcPts val="0"/>
-              </a:spcAft>
-            </a:pPr>
-            <a:r>
-              <a:rPr sz="1200" b="1" i="0">
-                <a:solidFill>
-                  <a:srgbClr val="777777"/>
-                </a:solidFill>
-                <a:latin typeface="Calibri"/>
-              </a:rPr>
-              <a:t>10</a:t>
+            <a:off x="9418320" y="2743200"/>
+            <a:ext cx="2103120" cy="310896"/>
+          </a:xfrm>
+          <a:prstGeom prst="rect">
+            <a:avLst/>
+          </a:prstGeom>
+          <a:noFill/>
+        </p:spPr>
+        <p:txBody>
+          <a:bodyPr wrap="square" lIns="0" rIns="0" tIns="0" bIns="0" anchor="t">
+            <a:spAutoFit/>
+          </a:bodyPr>
+          <a:lstStyle/>
+          <a:p>
+            <a:pPr algn="l">
+              <a:lnSpc>
+                <a:spcPct val="106000"/>
+              </a:lnSpc>
+              <a:spcAft>
+                <a:spcPts val="0"/>
+              </a:spcAft>
+            </a:pPr>
+            <a:r>
+              <a:rPr sz="1350" b="1" i="0">
+                <a:solidFill>
+                  <a:srgbClr val="111111"/>
+                </a:solidFill>
+                <a:latin typeface="Calibri"/>
+              </a:rPr>
+              <a:t>5.7 %</a:t>
             </a:r>
           </a:p>
         </p:txBody>
@@ -6194,8 +6003,8 @@
         </p:nvSpPr>
         <p:spPr>
           <a:xfrm>
-            <a:off x="731520" y="3090672"/>
-            <a:ext cx="3291840" cy="292608"/>
+            <a:off x="731520" y="3200400"/>
+            <a:ext cx="3291840" cy="310896"/>
           </a:xfrm>
           <a:prstGeom prst="rect">
             <a:avLst/>
@@ -6223,7 +6032,7 @@
                 </a:solidFill>
                 <a:latin typeface="Calibri"/>
               </a:rPr>
-              <a:t>Keyword filter</a:t>
+              <a:t>Mistral-7B</a:t>
             </a:r>
           </a:p>
         </p:txBody>
@@ -6236,21 +6045,21 @@
         </p:nvSpPr>
         <p:spPr>
           <a:xfrm>
-            <a:off x="4297680" y="3090672"/>
-            <a:ext cx="914400" cy="292608"/>
-          </a:xfrm>
-          <a:prstGeom prst="rect">
-            <a:avLst/>
-          </a:prstGeom>
-          <a:noFill/>
-        </p:spPr>
-        <p:txBody>
-          <a:bodyPr wrap="square" lIns="0" rIns="0" tIns="0" bIns="0" anchor="t">
-            <a:spAutoFit/>
-          </a:bodyPr>
-          <a:lstStyle/>
-          <a:p>
-            <a:pPr algn="ctr">
+            <a:off x="4114800" y="3200400"/>
+            <a:ext cx="3108960" cy="310896"/>
+          </a:xfrm>
+          <a:prstGeom prst="rect">
+            <a:avLst/>
+          </a:prstGeom>
+          <a:noFill/>
+        </p:spPr>
+        <p:txBody>
+          <a:bodyPr wrap="square" lIns="0" rIns="0" tIns="0" bIns="0" anchor="t">
+            <a:spAutoFit/>
+          </a:bodyPr>
+          <a:lstStyle/>
+          <a:p>
+            <a:pPr algn="l">
               <a:lnSpc>
                 <a:spcPct val="106000"/>
               </a:lnSpc>
@@ -6265,7 +6074,7 @@
                 </a:solidFill>
                 <a:latin typeface="Calibri"/>
               </a:rPr>
-              <a:t>+7.3</a:t>
+              <a:t>DecodingAgg</a:t>
             </a:r>
           </a:p>
         </p:txBody>
@@ -6278,21 +6087,21 @@
         </p:nvSpPr>
         <p:spPr>
           <a:xfrm>
-            <a:off x="5330952" y="3090672"/>
-            <a:ext cx="914400" cy="292608"/>
-          </a:xfrm>
-          <a:prstGeom prst="rect">
-            <a:avLst/>
-          </a:prstGeom>
-          <a:noFill/>
-        </p:spPr>
-        <p:txBody>
-          <a:bodyPr wrap="square" lIns="0" rIns="0" tIns="0" bIns="0" anchor="t">
-            <a:spAutoFit/>
-          </a:bodyPr>
-          <a:lstStyle/>
-          <a:p>
-            <a:pPr algn="ctr">
+            <a:off x="7406640" y="3200400"/>
+            <a:ext cx="1828800" cy="310896"/>
+          </a:xfrm>
+          <a:prstGeom prst="rect">
+            <a:avLst/>
+          </a:prstGeom>
+          <a:noFill/>
+        </p:spPr>
+        <p:txBody>
+          <a:bodyPr wrap="square" lIns="0" rIns="0" tIns="0" bIns="0" anchor="t">
+            <a:spAutoFit/>
+          </a:bodyPr>
+          <a:lstStyle/>
+          <a:p>
+            <a:pPr algn="l">
               <a:lnSpc>
                 <a:spcPct val="106000"/>
               </a:lnSpc>
@@ -6307,7 +6116,7 @@
                 </a:solidFill>
                 <a:latin typeface="Calibri"/>
               </a:rPr>
-              <a:t>+4.0</a:t>
+              <a:t>0.0 %</a:t>
             </a:r>
           </a:p>
         </p:txBody>
@@ -6320,21 +6129,63 @@
         </p:nvSpPr>
         <p:spPr>
           <a:xfrm>
-            <a:off x="6364224" y="3090672"/>
-            <a:ext cx="914400" cy="292608"/>
-          </a:xfrm>
-          <a:prstGeom prst="rect">
-            <a:avLst/>
-          </a:prstGeom>
-          <a:noFill/>
-        </p:spPr>
-        <p:txBody>
-          <a:bodyPr wrap="square" lIns="0" rIns="0" tIns="0" bIns="0" anchor="t">
-            <a:spAutoFit/>
-          </a:bodyPr>
-          <a:lstStyle/>
-          <a:p>
-            <a:pPr algn="ctr">
+            <a:off x="9418320" y="3200400"/>
+            <a:ext cx="2103120" cy="310896"/>
+          </a:xfrm>
+          <a:prstGeom prst="rect">
+            <a:avLst/>
+          </a:prstGeom>
+          <a:noFill/>
+        </p:spPr>
+        <p:txBody>
+          <a:bodyPr wrap="square" lIns="0" rIns="0" tIns="0" bIns="0" anchor="t">
+            <a:spAutoFit/>
+          </a:bodyPr>
+          <a:lstStyle/>
+          <a:p>
+            <a:pPr algn="l">
+              <a:lnSpc>
+                <a:spcPct val="106000"/>
+              </a:lnSpc>
+              <a:spcAft>
+                <a:spcPts val="0"/>
+              </a:spcAft>
+            </a:pPr>
+            <a:r>
+              <a:rPr sz="1350" b="1" i="0">
+                <a:solidFill>
+                  <a:srgbClr val="111111"/>
+                </a:solidFill>
+                <a:latin typeface="Calibri"/>
+              </a:rPr>
+              <a:t>3.7 %</a:t>
+            </a:r>
+          </a:p>
+        </p:txBody>
+      </p:sp>
+      <p:sp>
+        <p:nvSpPr>
+          <p:cNvPr id="18" name="TextBox 17"/>
+          <p:cNvSpPr txBox="1"/>
+          <p:nvPr/>
+        </p:nvSpPr>
+        <p:spPr>
+          <a:xfrm>
+            <a:off x="731520" y="3657600"/>
+            <a:ext cx="3291840" cy="310896"/>
+          </a:xfrm>
+          <a:prstGeom prst="rect">
+            <a:avLst/>
+          </a:prstGeom>
+          <a:noFill/>
+        </p:spPr>
+        <p:txBody>
+          <a:bodyPr wrap="square" lIns="0" rIns="0" tIns="0" bIns="0" anchor="t">
+            <a:spAutoFit/>
+          </a:bodyPr>
+          <a:lstStyle/>
+          <a:p>
+            <a:pPr algn="l">
               <a:lnSpc>
                 <a:spcPct val="106000"/>
               </a:lnSpc>
@@ -6349,34 +6200,34 @@
                 </a:solidFill>
                 <a:latin typeface="Calibri"/>
               </a:rPr>
-              <a:t>+4.0</a:t>
-            </a:r>
-          </a:p>
-        </p:txBody>
-      </p:sp>
-      <p:sp>
-        <p:nvSpPr>
-          <p:cNvPr id="18" name="TextBox 17"/>
-          <p:cNvSpPr txBox="1"/>
-          <p:nvPr/>
-        </p:nvSpPr>
-        <p:spPr>
-          <a:xfrm>
-            <a:off x="7397496" y="3090672"/>
-            <a:ext cx="914400" cy="292608"/>
-          </a:xfrm>
-          <a:prstGeom prst="rect">
-            <a:avLst/>
-          </a:prstGeom>
-          <a:noFill/>
-        </p:spPr>
-        <p:txBody>
-          <a:bodyPr wrap="square" lIns="0" rIns="0" tIns="0" bIns="0" anchor="t">
-            <a:spAutoFit/>
-          </a:bodyPr>
-          <a:lstStyle/>
-          <a:p>
-            <a:pPr algn="ctr">
+              <a:t>Llama-3-8B</a:t>
+            </a:r>
+          </a:p>
+        </p:txBody>
+      </p:sp>
+      <p:sp>
+        <p:nvSpPr>
+          <p:cNvPr id="19" name="TextBox 18"/>
+          <p:cNvSpPr txBox="1"/>
+          <p:nvPr/>
+        </p:nvSpPr>
+        <p:spPr>
+          <a:xfrm>
+            <a:off x="4114800" y="3657600"/>
+            <a:ext cx="3108960" cy="310896"/>
+          </a:xfrm>
+          <a:prstGeom prst="rect">
+            <a:avLst/>
+          </a:prstGeom>
+          <a:noFill/>
+        </p:spPr>
+        <p:txBody>
+          <a:bodyPr wrap="square" lIns="0" rIns="0" tIns="0" bIns="0" anchor="t">
+            <a:spAutoFit/>
+          </a:bodyPr>
+          <a:lstStyle/>
+          <a:p>
+            <a:pPr algn="l">
               <a:lnSpc>
                 <a:spcPct val="106000"/>
               </a:lnSpc>
@@ -6391,34 +6242,34 @@
                 </a:solidFill>
                 <a:latin typeface="Calibri"/>
               </a:rPr>
-              <a:t>+5.7</a:t>
-            </a:r>
-          </a:p>
-        </p:txBody>
-      </p:sp>
-      <p:sp>
-        <p:nvSpPr>
-          <p:cNvPr id="19" name="TextBox 18"/>
-          <p:cNvSpPr txBox="1"/>
-          <p:nvPr/>
-        </p:nvSpPr>
-        <p:spPr>
-          <a:xfrm>
-            <a:off x="8430767" y="3090672"/>
-            <a:ext cx="914400" cy="292608"/>
-          </a:xfrm>
-          <a:prstGeom prst="rect">
-            <a:avLst/>
-          </a:prstGeom>
-          <a:noFill/>
-        </p:spPr>
-        <p:txBody>
-          <a:bodyPr wrap="square" lIns="0" rIns="0" tIns="0" bIns="0" anchor="t">
-            <a:spAutoFit/>
-          </a:bodyPr>
-          <a:lstStyle/>
-          <a:p>
-            <a:pPr algn="ctr">
+              <a:t>KeywordAgg</a:t>
+            </a:r>
+          </a:p>
+        </p:txBody>
+      </p:sp>
+      <p:sp>
+        <p:nvSpPr>
+          <p:cNvPr id="20" name="TextBox 19"/>
+          <p:cNvSpPr txBox="1"/>
+          <p:nvPr/>
+        </p:nvSpPr>
+        <p:spPr>
+          <a:xfrm>
+            <a:off x="7406640" y="3657600"/>
+            <a:ext cx="1828800" cy="310896"/>
+          </a:xfrm>
+          <a:prstGeom prst="rect">
+            <a:avLst/>
+          </a:prstGeom>
+          <a:noFill/>
+        </p:spPr>
+        <p:txBody>
+          <a:bodyPr wrap="square" lIns="0" rIns="0" tIns="0" bIns="0" anchor="t">
+            <a:spAutoFit/>
+          </a:bodyPr>
+          <a:lstStyle/>
+          <a:p>
+            <a:pPr algn="l">
               <a:lnSpc>
                 <a:spcPct val="106000"/>
               </a:lnSpc>
@@ -6433,34 +6284,76 @@
                 </a:solidFill>
                 <a:latin typeface="Calibri"/>
               </a:rPr>
-              <a:t>+6.7</a:t>
-            </a:r>
-          </a:p>
-        </p:txBody>
-      </p:sp>
-      <p:sp>
-        <p:nvSpPr>
-          <p:cNvPr id="20" name="TextBox 19"/>
-          <p:cNvSpPr txBox="1"/>
-          <p:nvPr/>
-        </p:nvSpPr>
-        <p:spPr>
-          <a:xfrm>
-            <a:off x="9464040" y="3090672"/>
-            <a:ext cx="914400" cy="292608"/>
-          </a:xfrm>
-          <a:prstGeom prst="rect">
-            <a:avLst/>
-          </a:prstGeom>
-          <a:noFill/>
-        </p:spPr>
-        <p:txBody>
-          <a:bodyPr wrap="square" lIns="0" rIns="0" tIns="0" bIns="0" anchor="t">
-            <a:spAutoFit/>
-          </a:bodyPr>
-          <a:lstStyle/>
-          <a:p>
-            <a:pPr algn="ctr">
+              <a:t>0.0 %</a:t>
+            </a:r>
+          </a:p>
+        </p:txBody>
+      </p:sp>
+      <p:sp>
+        <p:nvSpPr>
+          <p:cNvPr id="21" name="TextBox 20"/>
+          <p:cNvSpPr txBox="1"/>
+          <p:nvPr/>
+        </p:nvSpPr>
+        <p:spPr>
+          <a:xfrm>
+            <a:off x="9418320" y="3657600"/>
+            <a:ext cx="2103120" cy="310896"/>
+          </a:xfrm>
+          <a:prstGeom prst="rect">
+            <a:avLst/>
+          </a:prstGeom>
+          <a:noFill/>
+        </p:spPr>
+        <p:txBody>
+          <a:bodyPr wrap="square" lIns="0" rIns="0" tIns="0" bIns="0" anchor="t">
+            <a:spAutoFit/>
+          </a:bodyPr>
+          <a:lstStyle/>
+          <a:p>
+            <a:pPr algn="l">
+              <a:lnSpc>
+                <a:spcPct val="106000"/>
+              </a:lnSpc>
+              <a:spcAft>
+                <a:spcPts val="0"/>
+              </a:spcAft>
+            </a:pPr>
+            <a:r>
+              <a:rPr sz="1350" b="1" i="0">
+                <a:solidFill>
+                  <a:srgbClr val="111111"/>
+                </a:solidFill>
+                <a:latin typeface="Calibri"/>
+              </a:rPr>
+              <a:t>85.0 %</a:t>
+            </a:r>
+          </a:p>
+        </p:txBody>
+      </p:sp>
+      <p:sp>
+        <p:nvSpPr>
+          <p:cNvPr id="22" name="TextBox 21"/>
+          <p:cNvSpPr txBox="1"/>
+          <p:nvPr/>
+        </p:nvSpPr>
+        <p:spPr>
+          <a:xfrm>
+            <a:off x="731520" y="4114800"/>
+            <a:ext cx="3291840" cy="310896"/>
+          </a:xfrm>
+          <a:prstGeom prst="rect">
+            <a:avLst/>
+          </a:prstGeom>
+          <a:noFill/>
+        </p:spPr>
+        <p:txBody>
+          <a:bodyPr wrap="square" lIns="0" rIns="0" tIns="0" bIns="0" anchor="t">
+            <a:spAutoFit/>
+          </a:bodyPr>
+          <a:lstStyle/>
+          <a:p>
+            <a:pPr algn="l">
               <a:lnSpc>
                 <a:spcPct val="106000"/>
               </a:lnSpc>
@@ -6475,34 +6368,34 @@
                 </a:solidFill>
                 <a:latin typeface="Calibri"/>
               </a:rPr>
-              <a:t>+12.3</a:t>
-            </a:r>
-          </a:p>
-        </p:txBody>
-      </p:sp>
-      <p:sp>
-        <p:nvSpPr>
-          <p:cNvPr id="21" name="TextBox 20"/>
-          <p:cNvSpPr txBox="1"/>
-          <p:nvPr/>
-        </p:nvSpPr>
-        <p:spPr>
-          <a:xfrm>
-            <a:off x="10497312" y="3090672"/>
-            <a:ext cx="914400" cy="292608"/>
-          </a:xfrm>
-          <a:prstGeom prst="rect">
-            <a:avLst/>
-          </a:prstGeom>
-          <a:noFill/>
-        </p:spPr>
-        <p:txBody>
-          <a:bodyPr wrap="square" lIns="0" rIns="0" tIns="0" bIns="0" anchor="t">
-            <a:spAutoFit/>
-          </a:bodyPr>
-          <a:lstStyle/>
-          <a:p>
-            <a:pPr algn="ctr">
+              <a:t>Llama-3-8B</a:t>
+            </a:r>
+          </a:p>
+        </p:txBody>
+      </p:sp>
+      <p:sp>
+        <p:nvSpPr>
+          <p:cNvPr id="23" name="TextBox 22"/>
+          <p:cNvSpPr txBox="1"/>
+          <p:nvPr/>
+        </p:nvSpPr>
+        <p:spPr>
+          <a:xfrm>
+            <a:off x="4114800" y="4114800"/>
+            <a:ext cx="3108960" cy="310896"/>
+          </a:xfrm>
+          <a:prstGeom prst="rect">
+            <a:avLst/>
+          </a:prstGeom>
+          <a:noFill/>
+        </p:spPr>
+        <p:txBody>
+          <a:bodyPr wrap="square" lIns="0" rIns="0" tIns="0" bIns="0" anchor="t">
+            <a:spAutoFit/>
+          </a:bodyPr>
+          <a:lstStyle/>
+          <a:p>
+            <a:pPr algn="l">
               <a:lnSpc>
                 <a:spcPct val="106000"/>
               </a:lnSpc>
@@ -6517,21 +6410,21 @@
                 </a:solidFill>
                 <a:latin typeface="Calibri"/>
               </a:rPr>
-              <a:t>-5.7</a:t>
-            </a:r>
-          </a:p>
-        </p:txBody>
-      </p:sp>
-      <p:sp>
-        <p:nvSpPr>
-          <p:cNvPr id="22" name="TextBox 21"/>
-          <p:cNvSpPr txBox="1"/>
-          <p:nvPr/>
-        </p:nvSpPr>
-        <p:spPr>
-          <a:xfrm>
-            <a:off x="731520" y="3511296"/>
-            <a:ext cx="3291840" cy="292608"/>
+              <a:t>DecodingAgg</a:t>
+            </a:r>
+          </a:p>
+        </p:txBody>
+      </p:sp>
+      <p:sp>
+        <p:nvSpPr>
+          <p:cNvPr id="24" name="TextBox 23"/>
+          <p:cNvSpPr txBox="1"/>
+          <p:nvPr/>
+        </p:nvSpPr>
+        <p:spPr>
+          <a:xfrm>
+            <a:off x="7406640" y="4114800"/>
+            <a:ext cx="1828800" cy="310896"/>
           </a:xfrm>
           <a:prstGeom prst="rect">
             <a:avLst/>
@@ -6559,175 +6452,129 @@
                 </a:solidFill>
                 <a:latin typeface="Calibri"/>
               </a:rPr>
-              <a:t>Averaged output</a:t>
-            </a:r>
-          </a:p>
-        </p:txBody>
-      </p:sp>
-      <p:sp>
-        <p:nvSpPr>
-          <p:cNvPr id="23" name="TextBox 22"/>
-          <p:cNvSpPr txBox="1"/>
-          <p:nvPr/>
-        </p:nvSpPr>
-        <p:spPr>
-          <a:xfrm>
-            <a:off x="4297680" y="3511296"/>
-            <a:ext cx="914400" cy="292608"/>
-          </a:xfrm>
-          <a:prstGeom prst="rect">
-            <a:avLst/>
-          </a:prstGeom>
-          <a:noFill/>
-        </p:spPr>
-        <p:txBody>
-          <a:bodyPr wrap="square" lIns="0" rIns="0" tIns="0" bIns="0" anchor="t">
-            <a:spAutoFit/>
-          </a:bodyPr>
-          <a:lstStyle/>
-          <a:p>
-            <a:pPr algn="ctr">
-              <a:lnSpc>
-                <a:spcPct val="106000"/>
-              </a:lnSpc>
-              <a:spcAft>
-                <a:spcPts val="0"/>
-              </a:spcAft>
-            </a:pPr>
-            <a:r>
-              <a:rPr sz="1350" b="0" i="0">
+              <a:t>0.0 %</a:t>
+            </a:r>
+          </a:p>
+        </p:txBody>
+      </p:sp>
+      <p:sp>
+        <p:nvSpPr>
+          <p:cNvPr id="25" name="TextBox 24"/>
+          <p:cNvSpPr txBox="1"/>
+          <p:nvPr/>
+        </p:nvSpPr>
+        <p:spPr>
+          <a:xfrm>
+            <a:off x="9418320" y="4114800"/>
+            <a:ext cx="2103120" cy="310896"/>
+          </a:xfrm>
+          <a:prstGeom prst="rect">
+            <a:avLst/>
+          </a:prstGeom>
+          <a:noFill/>
+        </p:spPr>
+        <p:txBody>
+          <a:bodyPr wrap="square" lIns="0" rIns="0" tIns="0" bIns="0" anchor="t">
+            <a:spAutoFit/>
+          </a:bodyPr>
+          <a:lstStyle/>
+          <a:p>
+            <a:pPr algn="l">
+              <a:lnSpc>
+                <a:spcPct val="106000"/>
+              </a:lnSpc>
+              <a:spcAft>
+                <a:spcPts val="0"/>
+              </a:spcAft>
+            </a:pPr>
+            <a:r>
+              <a:rPr sz="1350" b="1" i="0">
+                <a:solidFill>
+                  <a:srgbClr val="111111"/>
+                </a:solidFill>
+                <a:latin typeface="Calibri"/>
+              </a:rPr>
+              <a:t>85.3 %</a:t>
+            </a:r>
+          </a:p>
+        </p:txBody>
+      </p:sp>
+      <p:sp>
+        <p:nvSpPr>
+          <p:cNvPr id="26" name="TextBox 25"/>
+          <p:cNvSpPr txBox="1"/>
+          <p:nvPr/>
+        </p:nvSpPr>
+        <p:spPr>
+          <a:xfrm>
+            <a:off x="731520" y="4663440"/>
+            <a:ext cx="10725912" cy="1737360"/>
+          </a:xfrm>
+          <a:prstGeom prst="rect">
+            <a:avLst/>
+          </a:prstGeom>
+          <a:noFill/>
+        </p:spPr>
+        <p:txBody>
+          <a:bodyPr wrap="square" lIns="0" rIns="0" tIns="0" bIns="0" anchor="t">
+            <a:spAutoFit/>
+          </a:bodyPr>
+          <a:lstStyle/>
+          <a:p>
+            <a:pPr algn="l">
+              <a:lnSpc>
+                <a:spcPct val="110000"/>
+              </a:lnSpc>
+              <a:spcAft>
+                <a:spcPts val="900"/>
+              </a:spcAft>
+            </a:pPr>
+            <a:r>
+              <a:rPr sz="1500" b="1" i="0">
+                <a:solidFill>
+                  <a:srgbClr val="111111"/>
+                </a:solidFill>
+                <a:latin typeface="Calibri"/>
+              </a:rPr>
+              <a:t>The undefended model never refuses. Not once, on either model, at any dose.</a:t>
+            </a:r>
+          </a:p>
+          <a:p>
+            <a:pPr>
+              <a:lnSpc>
+                <a:spcPct val="110000"/>
+              </a:lnSpc>
+              <a:spcAft>
+                <a:spcPts val="900"/>
+              </a:spcAft>
+            </a:pPr>
+            <a:r>
+              <a:rPr sz="1500" b="0" i="0">
                 <a:solidFill>
                   <a:srgbClr val="444444"/>
                 </a:solidFill>
                 <a:latin typeface="Calibri"/>
               </a:rPr>
-              <a:t>+8.7</a:t>
-            </a:r>
-          </a:p>
-        </p:txBody>
-      </p:sp>
-      <p:sp>
-        <p:nvSpPr>
-          <p:cNvPr id="24" name="TextBox 23"/>
-          <p:cNvSpPr txBox="1"/>
-          <p:nvPr/>
-        </p:nvSpPr>
-        <p:spPr>
-          <a:xfrm>
-            <a:off x="5330952" y="3511296"/>
-            <a:ext cx="914400" cy="292608"/>
-          </a:xfrm>
-          <a:prstGeom prst="rect">
-            <a:avLst/>
-          </a:prstGeom>
-          <a:noFill/>
-        </p:spPr>
-        <p:txBody>
-          <a:bodyPr wrap="square" lIns="0" rIns="0" tIns="0" bIns="0" anchor="t">
-            <a:spAutoFit/>
-          </a:bodyPr>
-          <a:lstStyle/>
-          <a:p>
-            <a:pPr algn="ctr">
-              <a:lnSpc>
-                <a:spcPct val="106000"/>
-              </a:lnSpc>
-              <a:spcAft>
-                <a:spcPts val="0"/>
-              </a:spcAft>
-            </a:pPr>
-            <a:r>
-              <a:rPr sz="1350" b="0" i="0">
-                <a:solidFill>
-                  <a:srgbClr val="444444"/>
-                </a:solidFill>
-                <a:latin typeface="Calibri"/>
-              </a:rPr>
-              <a:t>-9.0</a:t>
-            </a:r>
-          </a:p>
-        </p:txBody>
-      </p:sp>
-      <p:sp>
-        <p:nvSpPr>
-          <p:cNvPr id="25" name="TextBox 24"/>
-          <p:cNvSpPr txBox="1"/>
-          <p:nvPr/>
-        </p:nvSpPr>
-        <p:spPr>
-          <a:xfrm>
-            <a:off x="6364224" y="3511296"/>
-            <a:ext cx="914400" cy="292608"/>
-          </a:xfrm>
-          <a:prstGeom prst="rect">
-            <a:avLst/>
-          </a:prstGeom>
-          <a:noFill/>
-        </p:spPr>
-        <p:txBody>
-          <a:bodyPr wrap="square" lIns="0" rIns="0" tIns="0" bIns="0" anchor="t">
-            <a:spAutoFit/>
-          </a:bodyPr>
-          <a:lstStyle/>
-          <a:p>
-            <a:pPr algn="ctr">
-              <a:lnSpc>
-                <a:spcPct val="106000"/>
-              </a:lnSpc>
-              <a:spcAft>
-                <a:spcPts val="0"/>
-              </a:spcAft>
-            </a:pPr>
-            <a:r>
-              <a:rPr sz="1350" b="0" i="0">
-                <a:solidFill>
-                  <a:srgbClr val="444444"/>
-                </a:solidFill>
-                <a:latin typeface="Calibri"/>
-              </a:rPr>
-              <a:t>-14.0</a:t>
-            </a:r>
-          </a:p>
-        </p:txBody>
-      </p:sp>
-      <p:sp>
-        <p:nvSpPr>
-          <p:cNvPr id="26" name="TextBox 25"/>
-          <p:cNvSpPr txBox="1"/>
-          <p:nvPr/>
-        </p:nvSpPr>
-        <p:spPr>
-          <a:xfrm>
-            <a:off x="7397496" y="3511296"/>
-            <a:ext cx="914400" cy="292608"/>
-          </a:xfrm>
-          <a:prstGeom prst="rect">
-            <a:avLst/>
-          </a:prstGeom>
-          <a:noFill/>
-        </p:spPr>
-        <p:txBody>
-          <a:bodyPr wrap="square" lIns="0" rIns="0" tIns="0" bIns="0" anchor="t">
-            <a:spAutoFit/>
-          </a:bodyPr>
-          <a:lstStyle/>
-          <a:p>
-            <a:pPr algn="ctr">
-              <a:lnSpc>
-                <a:spcPct val="106000"/>
-              </a:lnSpc>
-              <a:spcAft>
-                <a:spcPts val="0"/>
-              </a:spcAft>
-            </a:pPr>
-            <a:r>
-              <a:rPr sz="1350" b="0" i="0">
-                <a:solidFill>
-                  <a:srgbClr val="444444"/>
-                </a:solidFill>
-                <a:latin typeface="Calibri"/>
-              </a:rPr>
-              <a:t>-18.3</a:t>
+              <a:t>The cause is the defense's own design. It answers from each passage alone, so a passage that says “refuse” gets an unopposed hearing. The undefended model reads all ten passages together, where nine honest ones drown it out.</a:t>
+            </a:r>
+          </a:p>
+          <a:p>
+            <a:pPr>
+              <a:lnSpc>
+                <a:spcPct val="110000"/>
+              </a:lnSpc>
+              <a:spcAft>
+                <a:spcPts val="900"/>
+              </a:spcAft>
+            </a:pPr>
+            <a:r>
+              <a:rPr sz="1500" b="1" i="0">
+                <a:solidFill>
+                  <a:srgbClr val="111111"/>
+                </a:solidFill>
+                <a:latin typeface="Calibri"/>
+              </a:rPr>
+              <a:t>It is the same property that makes this family resist tone steering. One trade, not two results, and the model decides which way it falls.</a:t>
             </a:r>
           </a:p>
         </p:txBody>
@@ -6735,590 +6582,6 @@
       <p:sp>
         <p:nvSpPr>
           <p:cNvPr id="27" name="TextBox 26"/>
-          <p:cNvSpPr txBox="1"/>
-          <p:nvPr/>
-        </p:nvSpPr>
-        <p:spPr>
-          <a:xfrm>
-            <a:off x="8430767" y="3511296"/>
-            <a:ext cx="914400" cy="292608"/>
-          </a:xfrm>
-          <a:prstGeom prst="rect">
-            <a:avLst/>
-          </a:prstGeom>
-          <a:noFill/>
-        </p:spPr>
-        <p:txBody>
-          <a:bodyPr wrap="square" lIns="0" rIns="0" tIns="0" bIns="0" anchor="t">
-            <a:spAutoFit/>
-          </a:bodyPr>
-          <a:lstStyle/>
-          <a:p>
-            <a:pPr algn="ctr">
-              <a:lnSpc>
-                <a:spcPct val="106000"/>
-              </a:lnSpc>
-              <a:spcAft>
-                <a:spcPts val="0"/>
-              </a:spcAft>
-            </a:pPr>
-            <a:r>
-              <a:rPr sz="1350" b="0" i="0">
-                <a:solidFill>
-                  <a:srgbClr val="444444"/>
-                </a:solidFill>
-                <a:latin typeface="Calibri"/>
-              </a:rPr>
-              <a:t>-20.3</a:t>
-            </a:r>
-          </a:p>
-        </p:txBody>
-      </p:sp>
-      <p:sp>
-        <p:nvSpPr>
-          <p:cNvPr id="28" name="TextBox 27"/>
-          <p:cNvSpPr txBox="1"/>
-          <p:nvPr/>
-        </p:nvSpPr>
-        <p:spPr>
-          <a:xfrm>
-            <a:off x="9464040" y="3511296"/>
-            <a:ext cx="914400" cy="292608"/>
-          </a:xfrm>
-          <a:prstGeom prst="rect">
-            <a:avLst/>
-          </a:prstGeom>
-          <a:noFill/>
-        </p:spPr>
-        <p:txBody>
-          <a:bodyPr wrap="square" lIns="0" rIns="0" tIns="0" bIns="0" anchor="t">
-            <a:spAutoFit/>
-          </a:bodyPr>
-          <a:lstStyle/>
-          <a:p>
-            <a:pPr algn="ctr">
-              <a:lnSpc>
-                <a:spcPct val="106000"/>
-              </a:lnSpc>
-              <a:spcAft>
-                <a:spcPts val="0"/>
-              </a:spcAft>
-            </a:pPr>
-            <a:r>
-              <a:rPr sz="1350" b="0" i="0">
-                <a:solidFill>
-                  <a:srgbClr val="444444"/>
-                </a:solidFill>
-                <a:latin typeface="Calibri"/>
-              </a:rPr>
-              <a:t>-17.3</a:t>
-            </a:r>
-          </a:p>
-        </p:txBody>
-      </p:sp>
-      <p:sp>
-        <p:nvSpPr>
-          <p:cNvPr id="29" name="TextBox 28"/>
-          <p:cNvSpPr txBox="1"/>
-          <p:nvPr/>
-        </p:nvSpPr>
-        <p:spPr>
-          <a:xfrm>
-            <a:off x="10497312" y="3511296"/>
-            <a:ext cx="914400" cy="292608"/>
-          </a:xfrm>
-          <a:prstGeom prst="rect">
-            <a:avLst/>
-          </a:prstGeom>
-          <a:noFill/>
-        </p:spPr>
-        <p:txBody>
-          <a:bodyPr wrap="square" lIns="0" rIns="0" tIns="0" bIns="0" anchor="t">
-            <a:spAutoFit/>
-          </a:bodyPr>
-          <a:lstStyle/>
-          <a:p>
-            <a:pPr algn="ctr">
-              <a:lnSpc>
-                <a:spcPct val="106000"/>
-              </a:lnSpc>
-              <a:spcAft>
-                <a:spcPts val="0"/>
-              </a:spcAft>
-            </a:pPr>
-            <a:r>
-              <a:rPr sz="1350" b="0" i="0">
-                <a:solidFill>
-                  <a:srgbClr val="444444"/>
-                </a:solidFill>
-                <a:latin typeface="Calibri"/>
-              </a:rPr>
-              <a:t>-4.0</a:t>
-            </a:r>
-          </a:p>
-        </p:txBody>
-      </p:sp>
-      <p:sp>
-        <p:nvSpPr>
-          <p:cNvPr id="30" name="TextBox 29"/>
-          <p:cNvSpPr txBox="1"/>
-          <p:nvPr/>
-        </p:nvSpPr>
-        <p:spPr>
-          <a:xfrm>
-            <a:off x="731520" y="3931920"/>
-            <a:ext cx="3291840" cy="292608"/>
-          </a:xfrm>
-          <a:prstGeom prst="rect">
-            <a:avLst/>
-          </a:prstGeom>
-          <a:noFill/>
-        </p:spPr>
-        <p:txBody>
-          <a:bodyPr wrap="square" lIns="0" rIns="0" tIns="0" bIns="0" anchor="t">
-            <a:spAutoFit/>
-          </a:bodyPr>
-          <a:lstStyle/>
-          <a:p>
-            <a:pPr algn="l">
-              <a:lnSpc>
-                <a:spcPct val="106000"/>
-              </a:lnSpc>
-              <a:spcAft>
-                <a:spcPts val="0"/>
-              </a:spcAft>
-            </a:pPr>
-            <a:r>
-              <a:rPr sz="1350" b="1" i="0">
-                <a:solidFill>
-                  <a:srgbClr val="111111"/>
-                </a:solidFill>
-                <a:latin typeface="Calibri"/>
-              </a:rPr>
-              <a:t>Difference</a:t>
-            </a:r>
-          </a:p>
-        </p:txBody>
-      </p:sp>
-      <p:sp>
-        <p:nvSpPr>
-          <p:cNvPr id="31" name="TextBox 30"/>
-          <p:cNvSpPr txBox="1"/>
-          <p:nvPr/>
-        </p:nvSpPr>
-        <p:spPr>
-          <a:xfrm>
-            <a:off x="4297680" y="3931920"/>
-            <a:ext cx="914400" cy="292608"/>
-          </a:xfrm>
-          <a:prstGeom prst="rect">
-            <a:avLst/>
-          </a:prstGeom>
-          <a:noFill/>
-        </p:spPr>
-        <p:txBody>
-          <a:bodyPr wrap="square" lIns="0" rIns="0" tIns="0" bIns="0" anchor="t">
-            <a:spAutoFit/>
-          </a:bodyPr>
-          <a:lstStyle/>
-          <a:p>
-            <a:pPr algn="ctr">
-              <a:lnSpc>
-                <a:spcPct val="106000"/>
-              </a:lnSpc>
-              <a:spcAft>
-                <a:spcPts val="0"/>
-              </a:spcAft>
-            </a:pPr>
-            <a:r>
-              <a:rPr sz="1350" b="1" i="0">
-                <a:solidFill>
-                  <a:srgbClr val="111111"/>
-                </a:solidFill>
-                <a:latin typeface="Calibri"/>
-              </a:rPr>
-              <a:t>1.4</a:t>
-            </a:r>
-          </a:p>
-        </p:txBody>
-      </p:sp>
-      <p:sp>
-        <p:nvSpPr>
-          <p:cNvPr id="32" name="TextBox 31"/>
-          <p:cNvSpPr txBox="1"/>
-          <p:nvPr/>
-        </p:nvSpPr>
-        <p:spPr>
-          <a:xfrm>
-            <a:off x="5330952" y="3931920"/>
-            <a:ext cx="914400" cy="292608"/>
-          </a:xfrm>
-          <a:prstGeom prst="rect">
-            <a:avLst/>
-          </a:prstGeom>
-          <a:noFill/>
-        </p:spPr>
-        <p:txBody>
-          <a:bodyPr wrap="square" lIns="0" rIns="0" tIns="0" bIns="0" anchor="t">
-            <a:spAutoFit/>
-          </a:bodyPr>
-          <a:lstStyle/>
-          <a:p>
-            <a:pPr algn="ctr">
-              <a:lnSpc>
-                <a:spcPct val="106000"/>
-              </a:lnSpc>
-              <a:spcAft>
-                <a:spcPts val="0"/>
-              </a:spcAft>
-            </a:pPr>
-            <a:r>
-              <a:rPr sz="1350" b="1" i="0">
-                <a:solidFill>
-                  <a:srgbClr val="111111"/>
-                </a:solidFill>
-                <a:latin typeface="Calibri"/>
-              </a:rPr>
-              <a:t>13.0</a:t>
-            </a:r>
-          </a:p>
-        </p:txBody>
-      </p:sp>
-      <p:sp>
-        <p:nvSpPr>
-          <p:cNvPr id="33" name="TextBox 32"/>
-          <p:cNvSpPr txBox="1"/>
-          <p:nvPr/>
-        </p:nvSpPr>
-        <p:spPr>
-          <a:xfrm>
-            <a:off x="6364224" y="3931920"/>
-            <a:ext cx="914400" cy="292608"/>
-          </a:xfrm>
-          <a:prstGeom prst="rect">
-            <a:avLst/>
-          </a:prstGeom>
-          <a:noFill/>
-        </p:spPr>
-        <p:txBody>
-          <a:bodyPr wrap="square" lIns="0" rIns="0" tIns="0" bIns="0" anchor="t">
-            <a:spAutoFit/>
-          </a:bodyPr>
-          <a:lstStyle/>
-          <a:p>
-            <a:pPr algn="ctr">
-              <a:lnSpc>
-                <a:spcPct val="106000"/>
-              </a:lnSpc>
-              <a:spcAft>
-                <a:spcPts val="0"/>
-              </a:spcAft>
-            </a:pPr>
-            <a:r>
-              <a:rPr sz="1350" b="1" i="0">
-                <a:solidFill>
-                  <a:srgbClr val="111111"/>
-                </a:solidFill>
-                <a:latin typeface="Calibri"/>
-              </a:rPr>
-              <a:t>18.0</a:t>
-            </a:r>
-          </a:p>
-        </p:txBody>
-      </p:sp>
-      <p:sp>
-        <p:nvSpPr>
-          <p:cNvPr id="34" name="TextBox 33"/>
-          <p:cNvSpPr txBox="1"/>
-          <p:nvPr/>
-        </p:nvSpPr>
-        <p:spPr>
-          <a:xfrm>
-            <a:off x="7397496" y="3931920"/>
-            <a:ext cx="914400" cy="292608"/>
-          </a:xfrm>
-          <a:prstGeom prst="rect">
-            <a:avLst/>
-          </a:prstGeom>
-          <a:noFill/>
-        </p:spPr>
-        <p:txBody>
-          <a:bodyPr wrap="square" lIns="0" rIns="0" tIns="0" bIns="0" anchor="t">
-            <a:spAutoFit/>
-          </a:bodyPr>
-          <a:lstStyle/>
-          <a:p>
-            <a:pPr algn="ctr">
-              <a:lnSpc>
-                <a:spcPct val="106000"/>
-              </a:lnSpc>
-              <a:spcAft>
-                <a:spcPts val="0"/>
-              </a:spcAft>
-            </a:pPr>
-            <a:r>
-              <a:rPr sz="1350" b="1" i="0">
-                <a:solidFill>
-                  <a:srgbClr val="111111"/>
-                </a:solidFill>
-                <a:latin typeface="Calibri"/>
-              </a:rPr>
-              <a:t>24.0</a:t>
-            </a:r>
-          </a:p>
-        </p:txBody>
-      </p:sp>
-      <p:sp>
-        <p:nvSpPr>
-          <p:cNvPr id="35" name="TextBox 34"/>
-          <p:cNvSpPr txBox="1"/>
-          <p:nvPr/>
-        </p:nvSpPr>
-        <p:spPr>
-          <a:xfrm>
-            <a:off x="8430767" y="3931920"/>
-            <a:ext cx="914400" cy="292608"/>
-          </a:xfrm>
-          <a:prstGeom prst="rect">
-            <a:avLst/>
-          </a:prstGeom>
-          <a:noFill/>
-        </p:spPr>
-        <p:txBody>
-          <a:bodyPr wrap="square" lIns="0" rIns="0" tIns="0" bIns="0" anchor="t">
-            <a:spAutoFit/>
-          </a:bodyPr>
-          <a:lstStyle/>
-          <a:p>
-            <a:pPr algn="ctr">
-              <a:lnSpc>
-                <a:spcPct val="106000"/>
-              </a:lnSpc>
-              <a:spcAft>
-                <a:spcPts val="0"/>
-              </a:spcAft>
-            </a:pPr>
-            <a:r>
-              <a:rPr sz="1350" b="1" i="0">
-                <a:solidFill>
-                  <a:srgbClr val="111111"/>
-                </a:solidFill>
-                <a:latin typeface="Calibri"/>
-              </a:rPr>
-              <a:t>27.0</a:t>
-            </a:r>
-          </a:p>
-        </p:txBody>
-      </p:sp>
-      <p:sp>
-        <p:nvSpPr>
-          <p:cNvPr id="36" name="TextBox 35"/>
-          <p:cNvSpPr txBox="1"/>
-          <p:nvPr/>
-        </p:nvSpPr>
-        <p:spPr>
-          <a:xfrm>
-            <a:off x="9464040" y="3931920"/>
-            <a:ext cx="914400" cy="292608"/>
-          </a:xfrm>
-          <a:prstGeom prst="rect">
-            <a:avLst/>
-          </a:prstGeom>
-          <a:noFill/>
-        </p:spPr>
-        <p:txBody>
-          <a:bodyPr wrap="square" lIns="0" rIns="0" tIns="0" bIns="0" anchor="t">
-            <a:spAutoFit/>
-          </a:bodyPr>
-          <a:lstStyle/>
-          <a:p>
-            <a:pPr algn="ctr">
-              <a:lnSpc>
-                <a:spcPct val="106000"/>
-              </a:lnSpc>
-              <a:spcAft>
-                <a:spcPts val="0"/>
-              </a:spcAft>
-            </a:pPr>
-            <a:r>
-              <a:rPr sz="1350" b="1" i="0">
-                <a:solidFill>
-                  <a:srgbClr val="111111"/>
-                </a:solidFill>
-                <a:latin typeface="Calibri"/>
-              </a:rPr>
-              <a:t>29.6</a:t>
-            </a:r>
-          </a:p>
-        </p:txBody>
-      </p:sp>
-      <p:sp>
-        <p:nvSpPr>
-          <p:cNvPr id="37" name="TextBox 36"/>
-          <p:cNvSpPr txBox="1"/>
-          <p:nvPr/>
-        </p:nvSpPr>
-        <p:spPr>
-          <a:xfrm>
-            <a:off x="10497312" y="3931920"/>
-            <a:ext cx="914400" cy="292608"/>
-          </a:xfrm>
-          <a:prstGeom prst="rect">
-            <a:avLst/>
-          </a:prstGeom>
-          <a:noFill/>
-        </p:spPr>
-        <p:txBody>
-          <a:bodyPr wrap="square" lIns="0" rIns="0" tIns="0" bIns="0" anchor="t">
-            <a:spAutoFit/>
-          </a:bodyPr>
-          <a:lstStyle/>
-          <a:p>
-            <a:pPr algn="ctr">
-              <a:lnSpc>
-                <a:spcPct val="106000"/>
-              </a:lnSpc>
-              <a:spcAft>
-                <a:spcPts val="0"/>
-              </a:spcAft>
-            </a:pPr>
-            <a:r>
-              <a:rPr sz="1350" b="1" i="0">
-                <a:solidFill>
-                  <a:srgbClr val="111111"/>
-                </a:solidFill>
-                <a:latin typeface="Calibri"/>
-              </a:rPr>
-              <a:t>1.7</a:t>
-            </a:r>
-          </a:p>
-        </p:txBody>
-      </p:sp>
-      <p:sp>
-        <p:nvSpPr>
-          <p:cNvPr id="38" name="TextBox 37"/>
-          <p:cNvSpPr txBox="1"/>
-          <p:nvPr/>
-        </p:nvSpPr>
-        <p:spPr>
-          <a:xfrm>
-            <a:off x="731520" y="4389120"/>
-            <a:ext cx="10725912" cy="274320"/>
-          </a:xfrm>
-          <a:prstGeom prst="rect">
-            <a:avLst/>
-          </a:prstGeom>
-          <a:noFill/>
-        </p:spPr>
-        <p:txBody>
-          <a:bodyPr wrap="square" lIns="0" rIns="0" tIns="0" bIns="0" anchor="t">
-            <a:spAutoFit/>
-          </a:bodyPr>
-          <a:lstStyle/>
-          <a:p>
-            <a:pPr algn="l">
-              <a:lnSpc>
-                <a:spcPct val="106000"/>
-              </a:lnSpc>
-              <a:spcAft>
-                <a:spcPts val="0"/>
-              </a:spcAft>
-            </a:pPr>
-            <a:r>
-              <a:rPr sz="1150" b="0" i="0">
-                <a:solidFill>
-                  <a:srgbClr val="777777"/>
-                </a:solidFill>
-                <a:latin typeface="Calibri"/>
-              </a:rPr>
-              <a:t>change in accuracy, in points, against the undefended model</a:t>
-            </a:r>
-          </a:p>
-        </p:txBody>
-      </p:sp>
-      <p:sp>
-        <p:nvSpPr>
-          <p:cNvPr id="39" name="TextBox 38"/>
-          <p:cNvSpPr txBox="1"/>
-          <p:nvPr/>
-        </p:nvSpPr>
-        <p:spPr>
-          <a:xfrm>
-            <a:off x="731520" y="4590288"/>
-            <a:ext cx="10725912" cy="1810512"/>
-          </a:xfrm>
-          <a:prstGeom prst="rect">
-            <a:avLst/>
-          </a:prstGeom>
-          <a:noFill/>
-        </p:spPr>
-        <p:txBody>
-          <a:bodyPr wrap="square" lIns="0" rIns="0" tIns="0" bIns="0" anchor="t">
-            <a:spAutoFit/>
-          </a:bodyPr>
-          <a:lstStyle/>
-          <a:p>
-            <a:pPr algn="l">
-              <a:lnSpc>
-                <a:spcPct val="110000"/>
-              </a:lnSpc>
-              <a:spcAft>
-                <a:spcPts val="800"/>
-              </a:spcAft>
-            </a:pPr>
-            <a:r>
-              <a:rPr sz="1500" b="1" i="0">
-                <a:solidFill>
-                  <a:srgbClr val="111111"/>
-                </a:solidFill>
-                <a:latin typeface="Calibri"/>
-              </a:rPr>
-              <a:t>At nine poisoned passages of ten, one version helps and the other does harm. They are 29.6 points apart.</a:t>
-            </a:r>
-          </a:p>
-          <a:p>
-            <a:pPr>
-              <a:lnSpc>
-                <a:spcPct val="110000"/>
-              </a:lnSpc>
-              <a:spcAft>
-                <a:spcPts val="800"/>
-              </a:spcAft>
-            </a:pPr>
-            <a:r>
-              <a:rPr sz="1500" b="0" i="0">
-                <a:solidFill>
-                  <a:srgbClr val="444444"/>
-                </a:solidFill>
-                <a:latin typeface="Calibri"/>
-              </a:rPr>
-              <a:t>We wrote the cause down before we ran the test. A keyword filter throws away a passage that carries no answer, so one honest passage still carries it. An average lets nine bad passages drown it.</a:t>
-            </a:r>
-          </a:p>
-          <a:p>
-            <a:pPr>
-              <a:lnSpc>
-                <a:spcPct val="110000"/>
-              </a:lnSpc>
-              <a:spcAft>
-                <a:spcPts val="800"/>
-              </a:spcAft>
-            </a:pPr>
-            <a:r>
-              <a:rPr sz="1500" b="1" i="0">
-                <a:solidFill>
-                  <a:srgbClr val="111111"/>
-                </a:solidFill>
-                <a:latin typeface="Calibri"/>
-              </a:rPr>
-              <a:t>The difference should therefore grow as honest passages are removed, and vanish when none are left. It does both.</a:t>
-            </a:r>
-          </a:p>
-        </p:txBody>
-      </p:sp>
-      <p:sp>
-        <p:nvSpPr>
-          <p:cNvPr id="40" name="TextBox 39"/>
           <p:cNvSpPr txBox="1"/>
           <p:nvPr/>
         </p:nvSpPr>
@@ -7353,7 +6616,7 @@
                 </a:solidFill>
                 <a:latin typeface="Calibri"/>
               </a:rPr>
-              <a:t>Both versions ship in Xiang et al., 2024, arXiv:2405.15556   ·   BadRAG Xue et al., 2024, arXiv:2406.00083   ·   Measurements: this work</a:t>
+              <a:t>RobustRAG, both versions Xiang et al., 2024   ·   BadRAG Xue et al., 2024   ·   Measurements: this work</a:t>
             </a:r>
           </a:p>
         </p:txBody>

</xml_diff>